<commit_message>
Fix Undyne attack pattern, Add boss HP bar
</commit_message>
<xml_diff>
--- a/UndertaleBossFight_CodeOverview.pptx
+++ b/UndertaleBossFight_CodeOverview.pptx
@@ -2995,7 +2995,7 @@
                 <a:ea typeface="Calibri" pitchFamily="34" charset="-122"/>
                 <a:cs typeface="Calibri" pitchFamily="34" charset="-120"/>
               </a:rPr>
-              <a:t>110+</a:t>
+              <a:t>120+</a:t>
             </a:r>
             <a:endParaRPr lang="en-US" sz="3000" dirty="0"/>
           </a:p>
@@ -3109,7 +3109,7 @@
                 <a:ea typeface="Calibri" pitchFamily="34" charset="-122"/>
                 <a:cs typeface="Calibri" pitchFamily="34" charset="-120"/>
               </a:rPr>
-              <a:t>~19,200</a:t>
+              <a:t>~19,300</a:t>
             </a:r>
             <a:endParaRPr lang="en-US" sz="3000" dirty="0"/>
           </a:p>
@@ -15547,7 +15547,7 @@
                 <a:ea typeface="Calibri" pitchFamily="34" charset="-122"/>
                 <a:cs typeface="Calibri" pitchFamily="34" charset="-120"/>
               </a:rPr>
-              <a:t>Code-health pass — สะอาด, เขียว, ปรับ 1 จุดของจริง</a:t>
+              <a:t>ฟีเจอร์รอบนี้ + code-health — สะอาด, เขียว, เทสต์ผ่าน 36</a:t>
             </a:r>
             <a:endParaRPr lang="en-US" sz="2800" dirty="0"/>
           </a:p>
@@ -15839,7 +15839,7 @@
                 <a:ea typeface="Courier New" pitchFamily="34" charset="-122"/>
                 <a:cs typeface="Courier New" pitchFamily="34" charset="-120"/>
               </a:rPr>
-              <a:t>⚡ ปรับประสิทธิภาพ: EntityManager</a:t>
+              <a:t>⚡ ฟีเจอร์รอบนี้: หลอดเลือดบอส (อนิเมชัน)</a:t>
             </a:r>
             <a:endParaRPr lang="en-US" sz="1350" dirty="0"/>
           </a:p>
@@ -15885,7 +15885,7 @@
                 <a:ea typeface="Calibri" pitchFamily="34" charset="-122"/>
                 <a:cs typeface="Calibri" pitchFamily="34" charset="-120"/>
               </a:rPr>
-              <a:t>เดิม: ก็อปลิสต์ new ArrayList&lt;&gt;(active) 4 ครั้ง/เฟรม (begin/update/endStep + with) + 1 ใน render</a:t>
+              <a:t>เดิม: เลือดบอสเป็นข้อความ debug บรรทัดเดียวมุมบนซ้าย (ชื่อบอส + ตัวเลข HP)</a:t>
             </a:r>
             <a:endParaRPr lang="en-US" sz="1130" dirty="0"/>
           </a:p>
@@ -15909,7 +15909,7 @@
                 <a:ea typeface="Calibri" pitchFamily="34" charset="-122"/>
                 <a:cs typeface="Calibri" pitchFamily="34" charset="-120"/>
               </a:rPr>
-              <a:t>ใหม่: pass ต่อเฟรมวน active ตรง ๆ — ปลอดภัยเพราะ add/destroy เป็น deferred (active ไม่ถูกแก้ระหว่างเฟรม)</a:t>
+              <a:t>ใหม่: หลอดเลือดสีเขียวมุมบนขวา + เลขเลือดที่เหลือนับถอยหลัง — โดนตีแล้วหลอด ‘ไหล’ ลดลงเป็นอนิเมชัน</a:t>
             </a:r>
             <a:endParaRPr lang="en-US" sz="1130" dirty="0"/>
           </a:p>
@@ -15933,7 +15933,7 @@
                 <a:ea typeface="Calibri" pitchFamily="34" charset="-122"/>
                 <a:cs typeface="Calibri" pitchFamily="34" charset="-120"/>
               </a:rPr>
-              <a:t>render ใช้ buffer reuse (renderOrder) แทนสร้างลิสต์ใหม่</a:t>
+              <a:t>อยู่ใน BattleScene (โค้ดร่วม) ใช้กับบอสทุกตัว — bossHpShown ease 18%/เฟรม เข้าหา monsterhp จริง</a:t>
             </a:r>
             <a:endParaRPr lang="en-US" sz="1130" dirty="0"/>
           </a:p>
@@ -15957,7 +15957,7 @@
                 <a:ea typeface="Calibri" pitchFamily="34" charset="-122"/>
                 <a:cs typeface="Calibri" pitchFamily="34" charset="-120"/>
               </a:rPr>
-              <a:t>ผล: ตัด allocation ~5 ลิสต์/เฟรม, พฤติกรรมเหมือนเดิม 100%</a:t>
+              <a:t>ข้าม Mettaton EX ที่วาดมิเตอร์เอง (hideHpHeader) · HP เพิ่มตอนเปลี่ยนเฟส = snap ทันที</a:t>
             </a:r>
             <a:endParaRPr lang="en-US" sz="1130" dirty="0"/>
           </a:p>
@@ -16071,7 +16071,7 @@
                 <a:ea typeface="Calibri" pitchFamily="34" charset="-122"/>
                 <a:cs typeface="Calibri" pitchFamily="34" charset="-120"/>
               </a:rPr>
-              <a:t>ยืนยันก่อน-หลังแก้: เทสต์ผ่านเท่าเดิม (36) — การปรับ EntityManager เป็น behavior-preserving</a:t>
+              <a:t>ยืนยันก่อน-หลังแก้: เทสต์ผ่านเท่าเดิม (36) — ฟีเจอร์เพิ่มเข้ามาโดยไม่กระทบตรรกะเดิม</a:t>
             </a:r>
             <a:endParaRPr lang="en-US" sz="1300" dirty="0"/>
           </a:p>
@@ -16110,7 +16110,7 @@
                 <a:ea typeface="Calibri" pitchFamily="34" charset="-122"/>
                 <a:cs typeface="Calibri" pitchFamily="34" charset="-120"/>
               </a:rPr>
-              <a:t>เหตุผลที่ไม่รื้อคอมเมนต์ทั้ง 19k บรรทัด: โค้ดมี javadoc/คอมเมนต์ละเอียดครบอยู่แล้ว — การ re-comment ยกชุดคือ churn ที่เพิ่มความเสี่ยงโดยไม่ได้คุณค่า จึงเพิ่มคอมเมนต์เฉพาะจุดที่แก้จริง (EntityManager invariant)</a:t>
+              <a:t>เหตุผลที่ไม่รื้อคอมเมนต์ทั้ง 19k บรรทัด: โค้ดมี javadoc/คอมเมนต์ละเอียดครบอยู่แล้ว — การ re-comment ยกชุดคือ churn ที่เพิ่มความเสี่ยงโดยไม่ได้คุณค่า จึงเพิ่มคอมเมนต์เฉพาะจุดที่แก้จริง (หลอดเลือดบอสใน BattleScene)</a:t>
             </a:r>
             <a:endParaRPr lang="en-US" sz="1200" dirty="0"/>
           </a:p>

</xml_diff>